<commit_message>
Pitch material rechecked against what is built
- Removed three overclaims from the slides and the script: live satellite colours per square, no name stored, a brief for all 33 districts
- Pitch_Script.md reorganised: Round 1, Round 2, what is real and what is not, number checklist, older material at the end
- Both PowerPoint files rebuilt and validated; notes match the script
- STATUS.md and PROGRESS.md updated
</commit_message>
<xml_diff>
--- a/design/Jutyar_Pitch_Round1.pptx
+++ b/design/Jutyar_Pitch_Round1.pptx
@@ -649,7 +649,7 @@
           <a:lstStyle/>
           <a:p>
             <a:r>
-              <a:t>0:10 to 1:15. DEMO ON THE PHONE. This is running now, on a real server. I sign in with my phone number and an SMS code. This is my farm. I walked its corners and marked my crops. Every square is 10 metres, checked from space. I asked a question with a photo, and this is the answer, in Sorani. And this is Alwa, the marketplace: my tomatoes are on sale, and other farmers see them on their phones.</a:t>
+              <a:t>0:10 to 1:15. DEMO ON THE PHONE. This is running now, on a real server. I sign in with my phone number and an SMS code. This is my farm. I walked its corners and marked my crops. The app cuts it into 10 metre squares, the size of one satellite pixel. Here is my 10-day plan from the live forecast. I asked a question with a photo, and this is the answer, in Sorani. And this is Alwa, the marketplace: my tomatoes are on sale, and other farmers see them on their phones.</a:t>
             </a:r>
           </a:p>
         </p:txBody>
@@ -719,7 +719,7 @@
           <a:lstStyle/>
           <a:p>
             <a:r>
-              <a:t>1:15 to 1:50. AI is the translator. The satellite, the forecast and the field's history are only numbers. An AI model turns them, with the farmer's photo, into advice in Sorani, and it says when it is unsure. Every night another AI agent writes a brief on all 33 districts. And we built all of this with AI: Claude, Codex and Pencil.</a:t>
+              <a:t>1:15 to 1:50. AI is the translator. The satellite, the forecast and the field's history are only numbers. An AI model turns them, with the farmer's photo, into advice in Sorani, and it says when it is unsure. Every night another AI agent writes the daily brief for the region. And we built all of this with AI: Claude, Codex and Pencil.</a:t>
             </a:r>
           </a:p>
         </p:txBody>

</xml_diff>

<commit_message>
Pitch no longer claims 215 advisers
- The 2024 study gives 215 as its research population, not a total of extension advisers
- Problem slide and both scripts now say tens of thousands of farmers with limited access to advice
- PowerPoint files rebuilt; STATUS.md and PROGRESS.md updated
</commit_message>
<xml_diff>
--- a/design/Jutyar_Pitch_Round1.pptx
+++ b/design/Jutyar_Pitch_Round1.pptx
@@ -579,7 +579,7 @@
           <a:lstStyle/>
           <a:p>
             <a:r>
-              <a:t>0:00 to 0:10. Kurdistan has about 50,000 wheat farmers and only about 215 advisers. Jutyar puts an adviser in every farmer's pocket. Let me show you.</a:t>
+              <a:t>0:00 to 0:10. Kurdistan has tens of thousands of farmers, but access to extension advice is limited. Jutyar puts an adviser in every farmer's pocket. Let me show you.</a:t>
             </a:r>
           </a:p>
         </p:txBody>
@@ -4049,7 +4049,7 @@
       <p:grpSpPr/>
       <p:pic>
         <p:nvPicPr>
-          <p:cNvPr id="2" name="Problem: 50,000 farmers, 215 advisers" descr="Problem: 50,000 farmers, 215 advisers"/>
+          <p:cNvPr id="2" name="Problem: thousands of farmers, too little advice" descr="Problem: thousands of farmers, too little advice"/>
           <p:cNvPicPr>
             <a:picLocks noChangeAspect="1"/>
           </p:cNvPicPr>

</xml_diff>

<commit_message>
Round 1 deck set to the seven chosen slides
- Title, problem, built in two days, New for Kurdistan, AI, Alwa, close
- PowerPoint rebuilt with notes; Round 1 script rewritten to match (253 words)
- STATUS.md and PROGRESS.md updated
</commit_message>
<xml_diff>
--- a/design/Jutyar_Pitch_Round1.pptx
+++ b/design/Jutyar_Pitch_Round1.pptx
@@ -12,7 +12,6 @@
     <p:sldId id="260" r:id="rId12"/>
     <p:sldId id="261" r:id="rId13"/>
     <p:sldId id="262" r:id="rId14"/>
-    <p:sldId id="263" r:id="rId15"/>
   </p:sldIdLst>
   <p:sldSz cx="12191695" cy="6858000" type="screen4x3"/>
   <p:notesSz cx="6858000" cy="9144000"/>
@@ -649,7 +648,7 @@
           <a:lstStyle/>
           <a:p>
             <a:r>
-              <a:t>0:10 to 1:15. DEMO ON THE PHONE. This is running now, on a real server. I sign in with my phone number and an SMS code. This is my farm. I walked its corners and marked my crops. The app cuts it into 10 metre squares, the size of one satellite pixel. Here is my 10-day plan from the live forecast. I asked a question with a photo, and this is the answer, in Sorani. And this is Alwa, the marketplace: my tomatoes are on sale, and other farmers see them on their phones.</a:t>
+              <a:t>0:10 to 1:05. DEMO ON THE PHONE. This is running now, on a real server. I sign in with my phone number and an SMS code. This is my farm. I walked its corners and marked my crops. The app cuts it into 10 metre squares, the size of one satellite pixel. Here is my 10-day plan from the live forecast. I asked a question with a photo, and this is the answer, in Sorani.</a:t>
             </a:r>
           </a:p>
         </p:txBody>
@@ -719,7 +718,7 @@
           <a:lstStyle/>
           <a:p>
             <a:r>
-              <a:t>1:15 to 1:50. AI is the translator. The satellite, the forecast and the field's history are only numbers. An AI model turns them, with the farmer's photo, into advice in Sorani, and it says when it is unsure. Every night another AI agent writes the daily brief for the region. And we built all of this with AI: Claude, Codex and Pencil.</a:t>
+              <a:t>1:05 to 1:25. What is new? We found no farm AI in Kurdish. Jutyar maps the field in satellite-sized squares, answers in Sorani in one message, and puts the farmer and the Ministry on the same data.</a:t>
             </a:r>
           </a:p>
         </p:txBody>
@@ -789,7 +788,7 @@
           <a:lstStyle/>
           <a:p>
             <a:r>
-              <a:t>1:50 to 2:30. LAST SLIDE. Is it realistic? The data is free. The server is live, with about 2,000 tests. One AI answer costs half a cent. The Ministry gets its own website, with the farms, the alerts and the region on one map. We start with wheat farmers in Slemani. App, server and website, built in two days. This is Jutyar. Thank you.</a:t>
+              <a:t>1:25 to 1:55. AI is the translator. The satellite, the forecast and the field's history are only numbers. An AI model turns them, with the farmer's photo, into advice in Sorani, and it says when it is unsure. Every night another AI agent writes the daily brief for the region. And we built all of this with AI: Claude, Codex and Pencil.</a:t>
             </a:r>
           </a:p>
         </p:txBody>
@@ -859,7 +858,7 @@
           <a:lstStyle/>
           <a:p>
             <a:r>
-              <a:t>BACKUP FOR QUESTIONS. The website: the Control Room and the region dashboard. These pictures are designs with sample numbers.</a:t>
+              <a:t>1:55 to 2:10. And this is Alwa, the marketplace. My tomatoes are on sale, and other farmers see them on their phones.</a:t>
             </a:r>
           </a:p>
         </p:txBody>
@@ -929,77 +928,7 @@
           <a:lstStyle/>
           <a:p>
             <a:r>
-              <a:t>BACKUP FOR QUESTIONS. Alwa, the marketplace: see what is on sale, call the seller, put yours on sale.</a:t>
-            </a:r>
-          </a:p>
-        </p:txBody>
-      </p:sp>
-      <p:sp>
-        <p:nvSpPr>
-          <p:cNvPr id="4" name="Slide Number Placeholder 3"/>
-          <p:cNvSpPr>
-            <a:spLocks noGrp="1"/>
-          </p:cNvSpPr>
-          <p:nvPr>
-            <p:ph type="sldNum" idx="5" sz="quarter"/>
-          </p:nvPr>
-        </p:nvSpPr>
-        <p:spPr/>
-      </p:sp>
-    </p:spTree>
-  </p:cSld>
-  <p:clrMapOvr>
-    <a:masterClrMapping/>
-  </p:clrMapOvr>
-</p:notes>
-</file>
-
-<file path=ppt/notesSlides/notesSlide8.xml><?xml version="1.0" encoding="utf-8"?>
-<p:notes xmlns:a="http://schemas.openxmlformats.org/drawingml/2006/main" xmlns:p="http://schemas.openxmlformats.org/presentationml/2006/main" xmlns:r="http://schemas.openxmlformats.org/officeDocument/2006/relationships">
-  <p:cSld>
-    <p:spTree>
-      <p:nvGrpSpPr>
-        <p:cNvPr id="1" name=""/>
-        <p:cNvGrpSpPr/>
-        <p:nvPr/>
-      </p:nvGrpSpPr>
-      <p:grpSpPr>
-        <a:xfrm>
-          <a:off x="0" y="0"/>
-          <a:ext cx="0" cy="0"/>
-          <a:chOff x="0" y="0"/>
-          <a:chExt cx="0" cy="0"/>
-        </a:xfrm>
-      </p:grpSpPr>
-      <p:sp>
-        <p:nvSpPr>
-          <p:cNvPr id="2" name="Slide Image Placeholder 1"/>
-          <p:cNvSpPr>
-            <a:spLocks noGrp="1"/>
-          </p:cNvSpPr>
-          <p:nvPr>
-            <p:ph type="sldImg" idx="2"/>
-          </p:nvPr>
-        </p:nvSpPr>
-        <p:spPr/>
-      </p:sp>
-      <p:sp>
-        <p:nvSpPr>
-          <p:cNvPr id="3" name="Notes Placeholder 2"/>
-          <p:cNvSpPr>
-            <a:spLocks noGrp="1"/>
-          </p:cNvSpPr>
-          <p:nvPr>
-            <p:ph type="body" idx="3" sz="quarter"/>
-          </p:nvPr>
-        </p:nvSpPr>
-        <p:spPr/>
-        <p:txBody>
-          <a:bodyPr/>
-          <a:lstStyle/>
-          <a:p>
-            <a:r>
-              <a:t>BACKUP. The vision picture, if a judge asks where this goes next.</a:t>
+              <a:t>2:10 to 2:35. Is it realistic? The data is free, the server is live with about 2,000 tests, and one AI answer costs half a cent. The Ministry gets its own website. App, server and website, built in two days. Jutyar: from one farm to a smarter Kurdistan. Thank you.</a:t>
             </a:r>
           </a:p>
         </p:txBody>
@@ -4133,7 +4062,7 @@
       <p:grpSpPr/>
       <p:pic>
         <p:nvPicPr>
-          <p:cNvPr id="2" name="AI is the translator" descr="AI is the translator"/>
+          <p:cNvPr id="2" name="New for Kurdistan" descr="New for Kurdistan"/>
           <p:cNvPicPr>
             <a:picLocks noChangeAspect="1"/>
           </p:cNvPicPr>
@@ -4175,7 +4104,7 @@
       <p:grpSpPr/>
       <p:pic>
         <p:nvPicPr>
-          <p:cNvPr id="2" name="Ready to grow" descr="Ready to grow"/>
+          <p:cNvPr id="2" name="AI is the translator" descr="AI is the translator"/>
           <p:cNvPicPr>
             <a:picLocks noChangeAspect="1"/>
           </p:cNvPicPr>
@@ -4217,7 +4146,7 @@
       <p:grpSpPr/>
       <p:pic>
         <p:nvPicPr>
-          <p:cNvPr id="2" name="Backup: the website" descr="Backup: the website"/>
+          <p:cNvPr id="2" name="Alwa, the marketplace" descr="Alwa, the marketplace"/>
           <p:cNvPicPr>
             <a:picLocks noChangeAspect="1"/>
           </p:cNvPicPr>
@@ -4259,49 +4188,7 @@
       <p:grpSpPr/>
       <p:pic>
         <p:nvPicPr>
-          <p:cNvPr id="2" name="Backup: Alwa, the marketplace" descr="Backup: Alwa, the marketplace"/>
-          <p:cNvPicPr>
-            <a:picLocks noChangeAspect="1"/>
-          </p:cNvPicPr>
-          <p:nvPr/>
-        </p:nvPicPr>
-        <p:blipFill>
-          <a:blip r:embed="rId2"/>
-          <a:stretch>
-            <a:fillRect/>
-          </a:stretch>
-        </p:blipFill>
-        <p:spPr>
-          <a:xfrm>
-            <a:off x="0" y="0"/>
-            <a:ext cx="12191695" cy="6858000"/>
-          </a:xfrm>
-          <a:prstGeom prst="rect">
-            <a:avLst/>
-          </a:prstGeom>
-        </p:spPr>
-      </p:pic>
-    </p:spTree>
-  </p:cSld>
-  <p:clrMapOvr>
-    <a:masterClrMapping/>
-  </p:clrMapOvr>
-</p:sld>
-</file>
-
-<file path=ppt/slides/slide8.xml><?xml version="1.0" encoding="utf-8"?>
-<p:sld xmlns:a="http://schemas.openxmlformats.org/drawingml/2006/main" xmlns:p="http://schemas.openxmlformats.org/presentationml/2006/main" xmlns:r="http://schemas.openxmlformats.org/officeDocument/2006/relationships">
-  <p:cSld>
-    <p:spTree>
-      <p:nvGrpSpPr>
-        <p:cNvPr id="1" name=""/>
-        <p:cNvGrpSpPr/>
-        <p:nvPr/>
-      </p:nvGrpSpPr>
-      <p:grpSpPr/>
-      <p:pic>
-        <p:nvPicPr>
-          <p:cNvPr id="2" name="Backup: vision" descr="Backup: vision"/>
+          <p:cNvPr id="2" name="From one farm to a smarter Kurdistan" descr="From one farm to a smarter Kurdistan"/>
           <p:cNvPicPr>
             <a:picLocks noChangeAspect="1"/>
           </p:cNvPicPr>

</xml_diff>

<commit_message>
Round 1 deck: wordless demo slide and Who pays slide
- Nine slides: the seven chosen plus a logo-only slide for the live demo and a slide saying farmers and buyers pay
- PowerPoint, Pencil file and Round 1 script updated
- STATUS.md and PROGRESS.md updated
</commit_message>
<xml_diff>
--- a/design/Jutyar_Pitch_Round1.pptx
+++ b/design/Jutyar_Pitch_Round1.pptx
@@ -12,6 +12,8 @@
     <p:sldId id="260" r:id="rId12"/>
     <p:sldId id="261" r:id="rId13"/>
     <p:sldId id="262" r:id="rId14"/>
+    <p:sldId id="263" r:id="rId15"/>
+    <p:sldId id="264" r:id="rId16"/>
   </p:sldIdLst>
   <p:sldSz cx="12191695" cy="6858000" type="screen4x3"/>
   <p:notesSz cx="6858000" cy="9144000"/>
@@ -648,7 +650,7 @@
           <a:lstStyle/>
           <a:p>
             <a:r>
-              <a:t>0:10 to 1:05. DEMO ON THE PHONE. This is running now, on a real server. I sign in with my phone number and an SMS code. This is my farm. I walked its corners and marked my crops. The app cuts it into 10 metre squares, the size of one satellite pixel. Here is my 10-day plan from the live forecast. I asked a question with a photo, and this is the answer, in Sorani.</a:t>
+              <a:t>0:10 to 1:05. USE THE APP NOW. This is running now, on a real server. I sign in with my phone number and an SMS code. This is my farm. I walked its corners and marked my crops. The app cuts it into 10 metre squares, the size of one satellite pixel. Here is my 10-day plan from the live forecast. I asked a question with a photo, and this is the answer, in Sorani.</a:t>
             </a:r>
           </a:p>
         </p:txBody>
@@ -718,7 +720,7 @@
           <a:lstStyle/>
           <a:p>
             <a:r>
-              <a:t>1:05 to 1:25. What is new? We found no farm AI in Kurdish. Jutyar maps the field in satellite-sized squares, answers in Sorani in one message, and puts the farmer and the Ministry on the same data.</a:t>
+              <a:t>1:05 to 1:12. Everything you just saw was built in two days.</a:t>
             </a:r>
           </a:p>
         </p:txBody>
@@ -788,7 +790,7 @@
           <a:lstStyle/>
           <a:p>
             <a:r>
-              <a:t>1:25 to 1:55. AI is the translator. The satellite, the forecast and the field's history are only numbers. An AI model turns them, with the farmer's photo, into advice in Sorani, and it says when it is unsure. Every night another AI agent writes the daily brief for the region. And we built all of this with AI: Claude, Codex and Pencil.</a:t>
+              <a:t>1:12 to 1:30. What is new? We found no farm AI in Kurdish. Jutyar maps the field in satellite-sized squares, answers in Sorani in one message, and puts the farmer and the Ministry on the same data.</a:t>
             </a:r>
           </a:p>
         </p:txBody>
@@ -858,7 +860,7 @@
           <a:lstStyle/>
           <a:p>
             <a:r>
-              <a:t>1:55 to 2:10. And this is Alwa, the marketplace. My tomatoes are on sale, and other farmers see them on their phones.</a:t>
+              <a:t>1:30 to 2:00. AI is the translator. The satellite, the forecast and the field's history are only numbers. An AI model turns them, with the farmer's photo, into advice in Sorani, and it says when it is unsure. Every night another AI agent writes the daily brief for the region. And we built all of this with AI: Claude, Codex and Pencil.</a:t>
             </a:r>
           </a:p>
         </p:txBody>
@@ -928,7 +930,147 @@
           <a:lstStyle/>
           <a:p>
             <a:r>
-              <a:t>2:10 to 2:35. Is it realistic? The data is free, the server is live with about 2,000 tests, and one AI answer costs half a cent. The Ministry gets its own website. App, server and website, built in two days. Jutyar: from one farm to a smarter Kurdistan. Thank you.</a:t>
+              <a:t>2:00 to 2:12. And this is Alwa, the marketplace. My tomatoes are on sale, and other farmers see them on their phones.</a:t>
+            </a:r>
+          </a:p>
+        </p:txBody>
+      </p:sp>
+      <p:sp>
+        <p:nvSpPr>
+          <p:cNvPr id="4" name="Slide Number Placeholder 3"/>
+          <p:cNvSpPr>
+            <a:spLocks noGrp="1"/>
+          </p:cNvSpPr>
+          <p:nvPr>
+            <p:ph type="sldNum" idx="5" sz="quarter"/>
+          </p:nvPr>
+        </p:nvSpPr>
+        <p:spPr/>
+      </p:sp>
+    </p:spTree>
+  </p:cSld>
+  <p:clrMapOvr>
+    <a:masterClrMapping/>
+  </p:clrMapOvr>
+</p:notes>
+</file>
+
+<file path=ppt/notesSlides/notesSlide8.xml><?xml version="1.0" encoding="utf-8"?>
+<p:notes xmlns:a="http://schemas.openxmlformats.org/drawingml/2006/main" xmlns:p="http://schemas.openxmlformats.org/presentationml/2006/main" xmlns:r="http://schemas.openxmlformats.org/officeDocument/2006/relationships">
+  <p:cSld>
+    <p:spTree>
+      <p:nvGrpSpPr>
+        <p:cNvPr id="1" name=""/>
+        <p:cNvGrpSpPr/>
+        <p:nvPr/>
+      </p:nvGrpSpPr>
+      <p:grpSpPr>
+        <a:xfrm>
+          <a:off x="0" y="0"/>
+          <a:ext cx="0" cy="0"/>
+          <a:chOff x="0" y="0"/>
+          <a:chExt cx="0" cy="0"/>
+        </a:xfrm>
+      </p:grpSpPr>
+      <p:sp>
+        <p:nvSpPr>
+          <p:cNvPr id="2" name="Slide Image Placeholder 1"/>
+          <p:cNvSpPr>
+            <a:spLocks noGrp="1"/>
+          </p:cNvSpPr>
+          <p:nvPr>
+            <p:ph type="sldImg" idx="2"/>
+          </p:nvPr>
+        </p:nvSpPr>
+        <p:spPr/>
+      </p:sp>
+      <p:sp>
+        <p:nvSpPr>
+          <p:cNvPr id="3" name="Notes Placeholder 2"/>
+          <p:cNvSpPr>
+            <a:spLocks noGrp="1"/>
+          </p:cNvSpPr>
+          <p:nvPr>
+            <p:ph type="body" idx="3" sz="quarter"/>
+          </p:nvPr>
+        </p:nvSpPr>
+        <p:spPr/>
+        <p:txBody>
+          <a:bodyPr/>
+          <a:lstStyle/>
+          <a:p>
+            <a:r>
+              <a:t>2:12 to 2:22. Who pays? The people who use it: farmers and buyers pay to use the app.</a:t>
+            </a:r>
+          </a:p>
+        </p:txBody>
+      </p:sp>
+      <p:sp>
+        <p:nvSpPr>
+          <p:cNvPr id="4" name="Slide Number Placeholder 3"/>
+          <p:cNvSpPr>
+            <a:spLocks noGrp="1"/>
+          </p:cNvSpPr>
+          <p:nvPr>
+            <p:ph type="sldNum" idx="5" sz="quarter"/>
+          </p:nvPr>
+        </p:nvSpPr>
+        <p:spPr/>
+      </p:sp>
+    </p:spTree>
+  </p:cSld>
+  <p:clrMapOvr>
+    <a:masterClrMapping/>
+  </p:clrMapOvr>
+</p:notes>
+</file>
+
+<file path=ppt/notesSlides/notesSlide9.xml><?xml version="1.0" encoding="utf-8"?>
+<p:notes xmlns:a="http://schemas.openxmlformats.org/drawingml/2006/main" xmlns:p="http://schemas.openxmlformats.org/presentationml/2006/main" xmlns:r="http://schemas.openxmlformats.org/officeDocument/2006/relationships">
+  <p:cSld>
+    <p:spTree>
+      <p:nvGrpSpPr>
+        <p:cNvPr id="1" name=""/>
+        <p:cNvGrpSpPr/>
+        <p:nvPr/>
+      </p:nvGrpSpPr>
+      <p:grpSpPr>
+        <a:xfrm>
+          <a:off x="0" y="0"/>
+          <a:ext cx="0" cy="0"/>
+          <a:chOff x="0" y="0"/>
+          <a:chExt cx="0" cy="0"/>
+        </a:xfrm>
+      </p:grpSpPr>
+      <p:sp>
+        <p:nvSpPr>
+          <p:cNvPr id="2" name="Slide Image Placeholder 1"/>
+          <p:cNvSpPr>
+            <a:spLocks noGrp="1"/>
+          </p:cNvSpPr>
+          <p:nvPr>
+            <p:ph type="sldImg" idx="2"/>
+          </p:nvPr>
+        </p:nvSpPr>
+        <p:spPr/>
+      </p:sp>
+      <p:sp>
+        <p:nvSpPr>
+          <p:cNvPr id="3" name="Notes Placeholder 2"/>
+          <p:cNvSpPr>
+            <a:spLocks noGrp="1"/>
+          </p:cNvSpPr>
+          <p:nvPr>
+            <p:ph type="body" idx="3" sz="quarter"/>
+          </p:nvPr>
+        </p:nvSpPr>
+        <p:spPr/>
+        <p:txBody>
+          <a:bodyPr/>
+          <a:lstStyle/>
+          <a:p>
+            <a:r>
+              <a:t>2:22 to 2:40. The data is free, the server is live, and one AI answer costs half a cent. Jutyar: from one farm to a smarter Kurdistan. Thank you.</a:t>
             </a:r>
           </a:p>
         </p:txBody>
@@ -4020,7 +4162,7 @@
       <p:grpSpPr/>
       <p:pic>
         <p:nvPicPr>
-          <p:cNvPr id="2" name="Built in two days: five app screens" descr="Built in two days: five app screens"/>
+          <p:cNvPr id="2" name="Demo slide: logo only, no text" descr="Demo slide: logo only, no text"/>
           <p:cNvPicPr>
             <a:picLocks noChangeAspect="1"/>
           </p:cNvPicPr>
@@ -4062,7 +4204,7 @@
       <p:grpSpPr/>
       <p:pic>
         <p:nvPicPr>
-          <p:cNvPr id="2" name="New for Kurdistan" descr="New for Kurdistan"/>
+          <p:cNvPr id="2" name="Built in two days: five app screens" descr="Built in two days: five app screens"/>
           <p:cNvPicPr>
             <a:picLocks noChangeAspect="1"/>
           </p:cNvPicPr>
@@ -4104,7 +4246,7 @@
       <p:grpSpPr/>
       <p:pic>
         <p:nvPicPr>
-          <p:cNvPr id="2" name="AI is the translator" descr="AI is the translator"/>
+          <p:cNvPr id="2" name="New for Kurdistan" descr="New for Kurdistan"/>
           <p:cNvPicPr>
             <a:picLocks noChangeAspect="1"/>
           </p:cNvPicPr>
@@ -4146,6 +4288,48 @@
       <p:grpSpPr/>
       <p:pic>
         <p:nvPicPr>
+          <p:cNvPr id="2" name="AI is the translator" descr="AI is the translator"/>
+          <p:cNvPicPr>
+            <a:picLocks noChangeAspect="1"/>
+          </p:cNvPicPr>
+          <p:nvPr/>
+        </p:nvPicPr>
+        <p:blipFill>
+          <a:blip r:embed="rId2"/>
+          <a:stretch>
+            <a:fillRect/>
+          </a:stretch>
+        </p:blipFill>
+        <p:spPr>
+          <a:xfrm>
+            <a:off x="0" y="0"/>
+            <a:ext cx="12191695" cy="6858000"/>
+          </a:xfrm>
+          <a:prstGeom prst="rect">
+            <a:avLst/>
+          </a:prstGeom>
+        </p:spPr>
+      </p:pic>
+    </p:spTree>
+  </p:cSld>
+  <p:clrMapOvr>
+    <a:masterClrMapping/>
+  </p:clrMapOvr>
+</p:sld>
+</file>
+
+<file path=ppt/slides/slide7.xml><?xml version="1.0" encoding="utf-8"?>
+<p:sld xmlns:a="http://schemas.openxmlformats.org/drawingml/2006/main" xmlns:p="http://schemas.openxmlformats.org/presentationml/2006/main" xmlns:r="http://schemas.openxmlformats.org/officeDocument/2006/relationships">
+  <p:cSld>
+    <p:spTree>
+      <p:nvGrpSpPr>
+        <p:cNvPr id="1" name=""/>
+        <p:cNvGrpSpPr/>
+        <p:nvPr/>
+      </p:nvGrpSpPr>
+      <p:grpSpPr/>
+      <p:pic>
+        <p:nvPicPr>
           <p:cNvPr id="2" name="Alwa, the marketplace" descr="Alwa, the marketplace"/>
           <p:cNvPicPr>
             <a:picLocks noChangeAspect="1"/>
@@ -4176,7 +4360,49 @@
 </p:sld>
 </file>
 
-<file path=ppt/slides/slide7.xml><?xml version="1.0" encoding="utf-8"?>
+<file path=ppt/slides/slide8.xml><?xml version="1.0" encoding="utf-8"?>
+<p:sld xmlns:a="http://schemas.openxmlformats.org/drawingml/2006/main" xmlns:p="http://schemas.openxmlformats.org/presentationml/2006/main" xmlns:r="http://schemas.openxmlformats.org/officeDocument/2006/relationships">
+  <p:cSld>
+    <p:spTree>
+      <p:nvGrpSpPr>
+        <p:cNvPr id="1" name=""/>
+        <p:cNvGrpSpPr/>
+        <p:nvPr/>
+      </p:nvGrpSpPr>
+      <p:grpSpPr/>
+      <p:pic>
+        <p:nvPicPr>
+          <p:cNvPr id="2" name="Who pays: farmers and buyers" descr="Who pays: farmers and buyers"/>
+          <p:cNvPicPr>
+            <a:picLocks noChangeAspect="1"/>
+          </p:cNvPicPr>
+          <p:nvPr/>
+        </p:nvPicPr>
+        <p:blipFill>
+          <a:blip r:embed="rId2"/>
+          <a:stretch>
+            <a:fillRect/>
+          </a:stretch>
+        </p:blipFill>
+        <p:spPr>
+          <a:xfrm>
+            <a:off x="0" y="0"/>
+            <a:ext cx="12191695" cy="6858000"/>
+          </a:xfrm>
+          <a:prstGeom prst="rect">
+            <a:avLst/>
+          </a:prstGeom>
+        </p:spPr>
+      </p:pic>
+    </p:spTree>
+  </p:cSld>
+  <p:clrMapOvr>
+    <a:masterClrMapping/>
+  </p:clrMapOvr>
+</p:sld>
+</file>
+
+<file path=ppt/slides/slide9.xml><?xml version="1.0" encoding="utf-8"?>
 <p:sld xmlns:a="http://schemas.openxmlformats.org/drawingml/2006/main" xmlns:p="http://schemas.openxmlformats.org/presentationml/2006/main" xmlns:r="http://schemas.openxmlformats.org/officeDocument/2006/relationships">
   <p:cSld>
     <p:spTree>

</xml_diff>